<commit_message>
docs(portfolio): polish final narrative and presentation copy
- rewrite slide subtitles, captions and short body copy so each slide
  carries one message and leads into the next; numbers, scenario
  results and limits are unchanged
- slide 8 title now "어디까지 확인했나"; browser card names
  Chromium(Playwright)
- rewrite speaker notes as spoken Korean with where-to-look cues and
  slide-to-slide transitions; add docs/speaker-notes-ko.md with the
  same notes
- give notes-page placeholders explicit geometry so notes text wraps
  inside the page
- re-export the PDF from PowerPoint (12 pages, Malgun Gothic embedded)
</commit_message>
<xml_diff>
--- a/portfolio/FabAssure-SKhynix.pptx
+++ b/portfolio/FabAssure-SKhynix.pptx
@@ -494,7 +494,12 @@
             <p:ph type="sldImg"/>
           </p:nvPr>
         </p:nvSpPr>
-        <p:spPr/>
+        <p:spPr>
+          <a:xfrm>
+            <a:off x="685800" y="1143000"/>
+            <a:ext cx="5486400" cy="3086100"/>
+          </a:xfrm>
+        </p:spPr>
       </p:sp>
       <p:sp>
         <p:nvSpPr>
@@ -506,14 +511,40 @@
             <p:ph type="body" idx="1"/>
           </p:nvPr>
         </p:nvSpPr>
-        <p:spPr/>
+        <p:spPr>
+          <a:xfrm>
+            <a:off x="685800" y="4572000"/>
+            <a:ext cx="5486400" cy="6400800"/>
+          </a:xfrm>
+        </p:spPr>
         <p:txBody>
           <a:bodyPr/>
           <a:lstStyle/>
           <a:p>
             <a:r>
-              <a:rPr lang="en-US" dirty="0"/>
-              <a:t>FabAssure는 제조 변경을 여섯 단계로 기록하는 품질 관리 소프트웨어입니다. 핵심은 변경을 완료로 닫지 않고, 무엇을 어떤 근거로 누가 판단했는지, 그리고 그 판단이 이후 생산에서도 유지됐는지까지 확인하는 것입니다. 오른쪽은 실제 앱에서 시나리오를 끝까지 진행한 개요 화면입니다.</a:t>
+              <a:rPr lang="ko-KR" dirty="0"/>
+              <a:t>FabAssure는 제조 변경을 관리하는 소프트웨어입니다.</a:t>
+            </a:r>
+            <a:endParaRPr lang="en-US" dirty="0"/>
+          </a:p>
+          <a:p>
+            <a:r>
+              <a:rPr lang="ko-KR" dirty="0"/>
+              <a:t>레시피나 설비 모듈을 바꾸면 보통 승인 서명으로 변경이 끝납니다. 저는 그 뒤에 생산이 실제로 어땠는지까지 같은 기록에 남기고 싶었습니다. 왼쪽 문장이 그 뜻입니다.</a:t>
+            </a:r>
+            <a:endParaRPr lang="en-US" dirty="0"/>
+          </a:p>
+          <a:p>
+            <a:r>
+              <a:rPr lang="ko-KR" dirty="0"/>
+              <a:t>오른쪽은 합성 데이터로 시나리오를 끝까지 진행한 실제 앱 화면입니다.</a:t>
+            </a:r>
+            <a:endParaRPr lang="en-US" dirty="0"/>
+          </a:p>
+          <a:p>
+            <a:r>
+              <a:rPr lang="ko-KR" dirty="0"/>
+              <a:t>먼저 왜 여기서 출발했는지부터 말씀드리겠습니다.</a:t>
             </a:r>
             <a:endParaRPr lang="en-US" dirty="0"/>
           </a:p>
@@ -582,7 +613,12 @@
             <p:ph type="sldImg"/>
           </p:nvPr>
         </p:nvSpPr>
-        <p:spPr/>
+        <p:spPr>
+          <a:xfrm>
+            <a:off x="685800" y="1143000"/>
+            <a:ext cx="5486400" cy="3086100"/>
+          </a:xfrm>
+        </p:spPr>
       </p:sp>
       <p:sp>
         <p:nvSpPr>
@@ -594,14 +630,26 @@
             <p:ph type="body" idx="1"/>
           </p:nvPr>
         </p:nvSpPr>
-        <p:spPr/>
+        <p:spPr>
+          <a:xfrm>
+            <a:off x="685800" y="4572000"/>
+            <a:ext cx="5486400" cy="6400800"/>
+          </a:xfrm>
+        </p:spPr>
         <p:txBody>
           <a:bodyPr/>
           <a:lstStyle/>
           <a:p>
             <a:r>
-              <a:rPr lang="en-US" dirty="0"/>
-              <a:t>브라우저는 표시와 입력만 맡고, 상태 전이와 역할 분리, 근거 적합성과 효과성 판정은 서버와 도메인 규칙이 매 요청마다 다시 검사합니다. 기록은 SQLite에 보존되고 감사 기록은 해시 체인으로 이어집니다.</a:t>
+              <a:rPr lang="ko-KR" dirty="0"/>
+              <a:t>브라우저는 보여주고 입력받는 일만 합니다. 상태 전이, 역할 분리, 근거 적합성, 효과성 판정은 전부 서버의 도메인 규칙이 요청마다 다시 검사합니다.</a:t>
+            </a:r>
+            <a:endParaRPr lang="en-US" dirty="0"/>
+          </a:p>
+          <a:p>
+            <a:r>
+              <a:rPr lang="ko-KR" dirty="0"/>
+              <a:t>기록은 SQLite에 남고, 감사 기록은 해시 체인으로 이어집니다.</a:t>
             </a:r>
             <a:endParaRPr lang="en-US" dirty="0"/>
           </a:p>
@@ -670,7 +718,12 @@
             <p:ph type="sldImg"/>
           </p:nvPr>
         </p:nvSpPr>
-        <p:spPr/>
+        <p:spPr>
+          <a:xfrm>
+            <a:off x="685800" y="1143000"/>
+            <a:ext cx="5486400" cy="3086100"/>
+          </a:xfrm>
+        </p:spPr>
       </p:sp>
       <p:sp>
         <p:nvSpPr>
@@ -682,14 +735,26 @@
             <p:ph type="body" idx="1"/>
           </p:nvPr>
         </p:nvSpPr>
-        <p:spPr/>
+        <p:spPr>
+          <a:xfrm>
+            <a:off x="685800" y="4572000"/>
+            <a:ext cx="5486400" cy="6400800"/>
+          </a:xfrm>
+        </p:spPr>
         <p:txBody>
           <a:bodyPr/>
           <a:lstStyle/>
           <a:p>
             <a:r>
-              <a:rPr lang="en-US" dirty="0"/>
-              <a:t>변경과 사건의 저장 상태와 역할 분리 규칙입니다. 화면에 보이는 한국어 상태 이름은 표시용이고, 서버는 저장된 상태값으로 전이를 검사합니다.</a:t>
+              <a:rPr lang="ko-KR" dirty="0"/>
+              <a:t>변경과 사건의 저장 상태, 그리고 단계별로 기록할 수 없는 사람을 정리한 표입니다.</a:t>
+            </a:r>
+            <a:endParaRPr lang="en-US" dirty="0"/>
+          </a:p>
+          <a:p>
+            <a:r>
+              <a:rPr lang="ko-KR" dirty="0"/>
+              <a:t>화면의 한국어 상태 이름은 표시용이고, 서버는 저장된 상태값으로 전이를 검사합니다.</a:t>
             </a:r>
             <a:endParaRPr lang="en-US" dirty="0"/>
           </a:p>
@@ -758,7 +823,12 @@
             <p:ph type="sldImg"/>
           </p:nvPr>
         </p:nvSpPr>
-        <p:spPr/>
+        <p:spPr>
+          <a:xfrm>
+            <a:off x="685800" y="1143000"/>
+            <a:ext cx="5486400" cy="3086100"/>
+          </a:xfrm>
+        </p:spPr>
       </p:sp>
       <p:sp>
         <p:nvSpPr>
@@ -770,14 +840,26 @@
             <p:ph type="body" idx="1"/>
           </p:nvPr>
         </p:nvSpPr>
-        <p:spPr/>
+        <p:spPr>
+          <a:xfrm>
+            <a:off x="685800" y="4572000"/>
+            <a:ext cx="5486400" cy="6400800"/>
+          </a:xfrm>
+        </p:spPr>
         <p:txBody>
           <a:bodyPr/>
           <a:lstStyle/>
           <a:p>
             <a:r>
-              <a:rPr lang="en-US" dirty="0"/>
-              <a:t>개발은 계약, 구현, 자동 테스트, 실제 브라우저 확인의 순서를 반복했습니다. AI 코딩 도구는 구현과 검토를 빠르게 하는 데 썼고, 반영 여부는 항상 같은 테스트와 실행 확인으로 결정했습니다.</a:t>
+              <a:rPr lang="ko-KR" dirty="0"/>
+              <a:t>개발은 계약, 구현, 자동 테스트, 실제 브라우저 확인 순서로 반복했습니다.</a:t>
+            </a:r>
+            <a:endParaRPr lang="en-US" dirty="0"/>
+          </a:p>
+          <a:p>
+            <a:r>
+              <a:rPr lang="ko-KR" dirty="0"/>
+              <a:t>AI 코딩 도구는 구현과 검토에 썼고, 반영 여부는 늘 같은 테스트와 실행 확인으로 정했습니다. 제품이 실행될 때 외부 AI를 호출하지는 않습니다.</a:t>
             </a:r>
             <a:endParaRPr lang="en-US" dirty="0"/>
           </a:p>
@@ -846,7 +928,12 @@
             <p:ph type="sldImg"/>
           </p:nvPr>
         </p:nvSpPr>
-        <p:spPr/>
+        <p:spPr>
+          <a:xfrm>
+            <a:off x="685800" y="1143000"/>
+            <a:ext cx="5486400" cy="3086100"/>
+          </a:xfrm>
+        </p:spPr>
       </p:sp>
       <p:sp>
         <p:nvSpPr>
@@ -858,14 +945,40 @@
             <p:ph type="body" idx="1"/>
           </p:nvPr>
         </p:nvSpPr>
-        <p:spPr/>
+        <p:spPr>
+          <a:xfrm>
+            <a:off x="685800" y="4572000"/>
+            <a:ext cx="5486400" cy="6400800"/>
+          </a:xfrm>
+        </p:spPr>
         <p:txBody>
           <a:bodyPr/>
           <a:lstStyle/>
           <a:p>
             <a:r>
-              <a:rPr lang="en-US" dirty="0"/>
-              <a:t>현장에서 변경이 문제가 되는 순간은 대개 승인 이후입니다. 승인 서명은 있어도 어떤 기준과 근거로 통과시켰는지가 끊겨 있으면, 정비 뒤 결함이 늘었을 때 영향 범위를 다시 구성할 수 없습니다. 그래서 결정과 근거와 이후 결과를 하나의 기록으로 묶는 것에서 출발했습니다.</a:t>
+              <a:rPr lang="ko-KR" dirty="0"/>
+              <a:t>정렬 레시피를 바꾸고 승인까지 받았다고 해보겠습니다. 서명은 남습니다.</a:t>
+            </a:r>
+            <a:endParaRPr lang="en-US" dirty="0"/>
+          </a:p>
+          <a:p>
+            <a:r>
+              <a:rPr lang="ko-KR" dirty="0"/>
+              <a:t>그런데 몇 주 뒤 결함이 늘면, 그때 무슨 기준으로 통과시켰는지, 근거 데이터는 어디 있는지부터 다시 찾아야 합니다. 측정값과 AOI 결과가 각자 다른 시스템에 있으니까요.</a:t>
+            </a:r>
+            <a:endParaRPr lang="en-US" dirty="0"/>
+          </a:p>
+          <a:p>
+            <a:r>
+              <a:rPr lang="ko-KR" dirty="0"/>
+              <a:t>세 번째 칸, 정비 뒤에 결함이 늘어난 경우는 뒤에서 실제 화면으로 다시 보여드리겠습니다.</a:t>
+            </a:r>
+            <a:endParaRPr lang="en-US" dirty="0"/>
+          </a:p>
+          <a:p>
+            <a:r>
+              <a:rPr lang="ko-KR" dirty="0"/>
+              <a:t>출발점은 아래 한 줄입니다. 그러려면 무엇을 통과로 볼지부터 정해야 했습니다.</a:t>
             </a:r>
             <a:endParaRPr lang="en-US" dirty="0"/>
           </a:p>
@@ -934,7 +1047,12 @@
             <p:ph type="sldImg"/>
           </p:nvPr>
         </p:nvSpPr>
-        <p:spPr/>
+        <p:spPr>
+          <a:xfrm>
+            <a:off x="685800" y="1143000"/>
+            <a:ext cx="5486400" cy="3086100"/>
+          </a:xfrm>
+        </p:spPr>
       </p:sp>
       <p:sp>
         <p:nvSpPr>
@@ -946,14 +1064,47 @@
             <p:ph type="body" idx="1"/>
           </p:nvPr>
         </p:nvSpPr>
-        <p:spPr/>
+        <p:spPr>
+          <a:xfrm>
+            <a:off x="685800" y="4572000"/>
+            <a:ext cx="5486400" cy="6400800"/>
+          </a:xfrm>
+        </p:spPr>
         <p:txBody>
           <a:bodyPr/>
           <a:lstStyle/>
           <a:p>
             <a:r>
-              <a:rPr lang="en-US" dirty="0"/>
-              <a:t>구현보다 먼저 판단 기준을 정했습니다. 합격 기준은 측정 전에 승인되어야 하고, 근거는 측정과 AOI 원천 기록만 인정하며, 요청·검토·승인은 서로 다른 사람이 합니다. 특히 마지막 효과성 단계는 수락 뒤에도 후속 LOT으로 판단을 다시 확인하는 단계입니다.</a:t>
+              <a:rPr lang="ko-KR" dirty="0"/>
+              <a:t>코드를 쓰기 전에 정한 게 이 여섯 칸입니다.</a:t>
+            </a:r>
+            <a:endParaRPr lang="en-US" dirty="0"/>
+          </a:p>
+          <a:p>
+            <a:r>
+              <a:rPr lang="ko-KR" dirty="0"/>
+              <a:t>두 군데만 봐주시면 됩니다. 먼저 두 번째 칸입니다. 합격 기준은 측정 전에 승인합니다. 결과를 보고 나서 기준을 맞추는 일이 없게 하려는 겁니다.</a:t>
+            </a:r>
+            <a:endParaRPr lang="en-US" dirty="0"/>
+          </a:p>
+          <a:p>
+            <a:r>
+              <a:rPr lang="ko-KR" dirty="0"/>
+              <a:t>다음은 마지막 효과성 칸입니다. 수락한 뒤에도 후속 LOT이 충분히 쌓이기 전에는 종결할 수 없습니다.</a:t>
+            </a:r>
+            <a:endParaRPr lang="en-US" dirty="0"/>
+          </a:p>
+          <a:p>
+            <a:r>
+              <a:rPr lang="ko-KR" dirty="0"/>
+              <a:t>아래는 같은 여섯 단계가 실제 앱에 들어간 모습입니다.</a:t>
+            </a:r>
+            <a:endParaRPr lang="en-US" dirty="0"/>
+          </a:p>
+          <a:p>
+            <a:r>
+              <a:rPr lang="ko-KR" dirty="0"/>
+              <a:t>이 기준을 실제 변경에 걸어보면 어떻게 되는지 보겠습니다.</a:t>
             </a:r>
             <a:endParaRPr lang="en-US" dirty="0"/>
           </a:p>
@@ -1022,7 +1173,12 @@
             <p:ph type="sldImg"/>
           </p:nvPr>
         </p:nvSpPr>
-        <p:spPr/>
+        <p:spPr>
+          <a:xfrm>
+            <a:off x="685800" y="1143000"/>
+            <a:ext cx="5486400" cy="3086100"/>
+          </a:xfrm>
+        </p:spPr>
       </p:sp>
       <p:sp>
         <p:nvSpPr>
@@ -1034,14 +1190,40 @@
             <p:ph type="body" idx="1"/>
           </p:nvPr>
         </p:nvSpPr>
-        <p:spPr/>
+        <p:spPr>
+          <a:xfrm>
+            <a:off x="685800" y="4572000"/>
+            <a:ext cx="5486400" cy="6400800"/>
+          </a:xfrm>
+        </p:spPr>
         <p:txBody>
           <a:bodyPr/>
           <a:lstStyle/>
           <a:p>
             <a:r>
-              <a:rPr lang="en-US" dirty="0"/>
-              <a:t>R2 레시피의 첫 검증에서 정렬 편차 0.100 mm가 나와 기준 0.08 mm를 넘었습니다. 이 불합격 기록은 지우거나 덮어쓰지 않고, 요청자가 새 개정을 만들어 다시 검증했습니다. 두 번째 개정은 측정 100건과 AOI 검사 5건으로 0.052 mm, AOI 불량률 0.2 %, 중대 결함 0건을 확인했고, 두 개정이 같은 화면에 함께 남습니다.</a:t>
+              <a:rPr lang="ko-KR" dirty="0"/>
+              <a:t>정렬 레시피를 바꾸는 변경입니다. 핵심 특성을 건드리니까 규칙상 L3, 가장 높은 등급으로 분류됐습니다.</a:t>
+            </a:r>
+            <a:endParaRPr lang="en-US" dirty="0"/>
+          </a:p>
+          <a:p>
+            <a:r>
+              <a:rPr lang="ko-KR" dirty="0"/>
+              <a:t>첫 개정 R1에서 정렬 편차가 0.100 mm 나왔습니다. 기준이 0.08 mm니까 불합격입니다.</a:t>
+            </a:r>
+            <a:endParaRPr lang="en-US" dirty="0"/>
+          </a:p>
+          <a:p>
+            <a:r>
+              <a:rPr lang="ko-KR" dirty="0"/>
+              <a:t>여기서 보셨으면 하는 건 숫자보다, 이 불합격을 지우지 않았다는 점입니다. 수정한 뒤 R2 개정으로 다시 검증했고, 두 기록이 한 화면에 나란히 남습니다.</a:t>
+            </a:r>
+            <a:endParaRPr lang="en-US" dirty="0"/>
+          </a:p>
+          <a:p>
+            <a:r>
+              <a:rPr lang="ko-KR" dirty="0"/>
+              <a:t>R2는 기준 세 개를 모두 통과했습니다. 그럼 이 결과는 누가 승인할 수 있을까요.</a:t>
             </a:r>
             <a:endParaRPr lang="en-US" dirty="0"/>
           </a:p>
@@ -1110,7 +1292,12 @@
             <p:ph type="sldImg"/>
           </p:nvPr>
         </p:nvSpPr>
-        <p:spPr/>
+        <p:spPr>
+          <a:xfrm>
+            <a:off x="685800" y="1143000"/>
+            <a:ext cx="5486400" cy="3086100"/>
+          </a:xfrm>
+        </p:spPr>
       </p:sp>
       <p:sp>
         <p:nvSpPr>
@@ -1122,14 +1309,40 @@
             <p:ph type="body" idx="1"/>
           </p:nvPr>
         </p:nvSpPr>
-        <p:spPr/>
+        <p:spPr>
+          <a:xfrm>
+            <a:off x="685800" y="4572000"/>
+            <a:ext cx="5486400" cy="6400800"/>
+          </a:xfrm>
+        </p:spPr>
         <p:txBody>
           <a:bodyPr/>
           <a:lstStyle/>
           <a:p>
             <a:r>
-              <a:rPr lang="en-US" dirty="0"/>
-              <a:t>왼쪽은 요청자인 제조 엔지니어 역할로 변경 수락을 시도한 화면입니다. 화면은 차단 사유를 보여주지만, 실제 권한은 서버가 모든 요청마다 다시 검사합니다. 요청·검증·검토·수락은 서로 다른 사람이 기록해야 하고, 그 결과가 오른쪽 아래 독립 결정 기록입니다.</a:t>
+              <a:rPr lang="ko-KR" dirty="0"/>
+              <a:t>왼쪽은 요청자인 제조 엔지니어 역할로 수락을 시도한 화면입니다. 차단 사유가 뜨고, 승인자로 바꾸라고 안내합니다.</a:t>
+            </a:r>
+            <a:endParaRPr lang="en-US" dirty="0"/>
+          </a:p>
+          <a:p>
+            <a:r>
+              <a:rPr lang="ko-KR" dirty="0"/>
+              <a:t>다만 화면에서 막는 건 안내일 뿐이고, 실제 판정은 서버가 요청마다 다시 합니다.</a:t>
+            </a:r>
+            <a:endParaRPr lang="en-US" dirty="0"/>
+          </a:p>
+          <a:p>
+            <a:r>
+              <a:rPr lang="ko-KR" dirty="0"/>
+              <a:t>표는 단계별로 누가 기록할 수 없는지 정리한 것입니다. 오른쪽 아래가 R2에 실제로 남은 독립 결정이고, 검토자와 승인자가 따로 기록했습니다.</a:t>
+            </a:r>
+            <a:endParaRPr lang="en-US" dirty="0"/>
+          </a:p>
+          <a:p>
+            <a:r>
+              <a:rPr lang="ko-KR" dirty="0"/>
+              <a:t>여기까지는 변경을 들여올 때의 이야기입니다. 그런데 이상은 수락한 뒤 설비에서 생기기도 합니다.</a:t>
             </a:r>
             <a:endParaRPr lang="en-US" dirty="0"/>
           </a:p>
@@ -1198,7 +1411,12 @@
             <p:ph type="sldImg"/>
           </p:nvPr>
         </p:nvSpPr>
-        <p:spPr/>
+        <p:spPr>
+          <a:xfrm>
+            <a:off x="685800" y="1143000"/>
+            <a:ext cx="5486400" cy="3086100"/>
+          </a:xfrm>
+        </p:spPr>
       </p:sp>
       <p:sp>
         <p:nvSpPr>
@@ -1210,14 +1428,40 @@
             <p:ph type="body" idx="1"/>
           </p:nvPr>
         </p:nvSpPr>
-        <p:spPr/>
+        <p:spPr>
+          <a:xfrm>
+            <a:off x="685800" y="4572000"/>
+            <a:ext cx="5486400" cy="6400800"/>
+          </a:xfrm>
+        </p:spPr>
         <p:txBody>
           <a:bodyPr/>
           <a:lstStyle/>
           <a:p>
             <a:r>
-              <a:rPr lang="en-US" dirty="0"/>
-              <a:t>정비 뒤 기준점 인식 불량이 늘어난 사건입니다. 설비 이력의 정비 시각과 마지막 정상 관측(LKG) 구간으로 노출 구간을 계산하고, LOT을 확정 영향·노출 가능·불확실·제외로 나눕니다. 샘플 AOI만으로 정상을 증명할 수 없는 LOT-A-025는 불확실로 남기고, 독립 검토자가 LOT마다 이유를 적어 보류를 결정했습니다.</a:t>
+              <a:rPr lang="ko-KR" dirty="0"/>
+              <a:t>처음에 말씀드린 세 번째 문제입니다. 08-24 정비 뒤에 기준점 인식 불량이 늘었습니다.</a:t>
+            </a:r>
+            <a:endParaRPr lang="en-US" dirty="0"/>
+          </a:p>
+          <a:p>
+            <a:r>
+              <a:rPr lang="ko-KR" dirty="0"/>
+              <a:t>이럴 때 가장 먼저 나오는 질문은 어느 LOT까지 봐야 하느냐입니다. 정비 시각과 마지막 정상 관측, LKG로 노출 구간을 잡고 LOT을 네 가지로 나눴습니다.</a:t>
+            </a:r>
+            <a:endParaRPr lang="en-US" dirty="0"/>
+          </a:p>
+          <a:p>
+            <a:r>
+              <a:rPr lang="ko-KR" dirty="0"/>
+              <a:t>LOT-A-025를 봐주세요. 샘플 AOI만으로는 정상이라고 할 수 없어서, 제외하지 않고 불확실로 남겼습니다. 시스템이 정상이라고 추정하지 않게 한 겁니다. 보류는 검토자가 LOT마다 사유를 적고 결정했습니다.</a:t>
+            </a:r>
+            <a:endParaRPr lang="en-US" dirty="0"/>
+          </a:p>
+          <a:p>
+            <a:r>
+              <a:rPr lang="ko-KR" dirty="0"/>
+              <a:t>다시 변경으로 돌아가면, 수락했다고 추적이 끝나지도 않습니다.</a:t>
             </a:r>
             <a:endParaRPr lang="en-US" dirty="0"/>
           </a:p>
@@ -1286,7 +1530,12 @@
             <p:ph type="sldImg"/>
           </p:nvPr>
         </p:nvSpPr>
-        <p:spPr/>
+        <p:spPr>
+          <a:xfrm>
+            <a:off x="685800" y="1143000"/>
+            <a:ext cx="5486400" cy="3086100"/>
+          </a:xfrm>
+        </p:spPr>
       </p:sp>
       <p:sp>
         <p:nvSpPr>
@@ -1298,14 +1547,47 @@
             <p:ph type="body" idx="1"/>
           </p:nvPr>
         </p:nvSpPr>
-        <p:spPr/>
+        <p:spPr>
+          <a:xfrm>
+            <a:off x="685800" y="4572000"/>
+            <a:ext cx="5486400" cy="6400800"/>
+          </a:xfrm>
+        </p:spPr>
         <p:txBody>
           <a:bodyPr/>
           <a:lstStyle/>
           <a:p>
             <a:r>
-              <a:rPr lang="en-US" dirty="0"/>
-              <a:t>수락 직후 평가하면 후속 LOT이 없어 데이터 부족으로 기록되고, 이 상태로는 종결할 수 없습니다. 후속 11개 LOT이 쌓인 뒤 합격해 승인자가 종결했지만, 이후 평가에서 관련 설비 경보가 해결되지 않아 재개 필요가 나왔습니다. 품질 엔지니어가 재개했고, 이전 수락과 합격, 종결 결정은 지워지지 않고 이력에 남아 있습니다.</a:t>
+              <a:rPr lang="ko-KR" dirty="0"/>
+              <a:t>수락 당일 바로 평가하면 후속 LOT이 하나도 없습니다. 이건 합격이 아니라 데이터 부족이고, 이 상태로는 종결할 수 없습니다.</a:t>
+            </a:r>
+            <a:endParaRPr lang="en-US" dirty="0"/>
+          </a:p>
+          <a:p>
+            <a:r>
+              <a:rPr lang="ko-KR" dirty="0"/>
+              <a:t>08-23에는 후속 LOT이 필요한 만큼 쌓였고 합격이 나와서, 승인자가 모니터링을 종결했습니다.</a:t>
+            </a:r>
+            <a:endParaRPr lang="en-US" dirty="0"/>
+          </a:p>
+          <a:p>
+            <a:r>
+              <a:rPr lang="ko-KR" dirty="0"/>
+              <a:t>그런데 09-10 평가에서 관련 설비 경보가 아직 해결되지 않은 게 걸렸습니다. 결과는 재개 필요였고, 품질 엔지니어가 다시 열었습니다.</a:t>
+            </a:r>
+            <a:endParaRPr lang="en-US" dirty="0"/>
+          </a:p>
+          <a:p>
+            <a:r>
+              <a:rPr lang="ko-KR" dirty="0"/>
+              <a:t>오른쪽 재개 기록을 보시면 이전 종결이 '보존됨'으로 남아 있습니다.</a:t>
+            </a:r>
+            <a:endParaRPr lang="en-US" dirty="0"/>
+          </a:p>
+          <a:p>
+            <a:r>
+              <a:rPr lang="ko-KR" dirty="0"/>
+              <a:t>여기까지가 제품이 하는 일입니다. 이게 실제로 이렇게 동작하는지는 따로 확인했습니다.</a:t>
             </a:r>
             <a:endParaRPr lang="en-US" dirty="0"/>
           </a:p>
@@ -1374,7 +1656,12 @@
             <p:ph type="sldImg"/>
           </p:nvPr>
         </p:nvSpPr>
-        <p:spPr/>
+        <p:spPr>
+          <a:xfrm>
+            <a:off x="685800" y="1143000"/>
+            <a:ext cx="5486400" cy="3086100"/>
+          </a:xfrm>
+        </p:spPr>
       </p:sp>
       <p:sp>
         <p:nvSpPr>
@@ -1386,14 +1673,47 @@
             <p:ph type="body" idx="1"/>
           </p:nvPr>
         </p:nvSpPr>
-        <p:spPr/>
+        <p:spPr>
+          <a:xfrm>
+            <a:off x="685800" y="4572000"/>
+            <a:ext cx="5486400" cy="6400800"/>
+          </a:xfrm>
+        </p:spPr>
         <p:txBody>
           <a:bodyPr/>
           <a:lstStyle/>
           <a:p>
             <a:r>
-              <a:rPr lang="en-US" dirty="0"/>
-              <a:t>도메인 규칙은 자동 테스트 291개로 Windows에서 모두 통과했고, 배포 번들은 오프라인 검증기의 다섯 항목을 통과했습니다. 화면은 실제 앱을 브라우저로 조작해 변경 2건과 사건 1건을 끝까지 진행하며 콘솔 오류와 외부 요청이 없음을 확인했습니다. 다만 합성 데이터로 검증했으므로 실제 MES·설비 연동과 인증, 실제 공정 기준의 타당성은 증명 범위 밖입니다.</a:t>
+              <a:rPr lang="ko-KR" dirty="0"/>
+              <a:t>확인은 세 층으로 나눠서 했습니다.</a:t>
+            </a:r>
+            <a:endParaRPr lang="en-US" dirty="0"/>
+          </a:p>
+          <a:p>
+            <a:r>
+              <a:rPr lang="ko-KR" dirty="0"/>
+              <a:t>규칙은 자동 테스트로 봤고, Windows에서 291개 모두 통과했습니다. 배포 번들은 인터넷 없이 도는지 오프라인 검증기로 따로 확인했습니다.</a:t>
+            </a:r>
+            <a:endParaRPr lang="en-US" dirty="0"/>
+          </a:p>
+          <a:p>
+            <a:r>
+              <a:rPr lang="ko-KR" dirty="0"/>
+              <a:t>마지막으로 Playwright로 Chromium을 띄워 실제 앱을 조작하면서, 변경 두 건과 사건 한 건을 끝까지 진행했습니다. 콘솔 오류도, 밖으로 나가는 요청도 없었습니다.</a:t>
+            </a:r>
+            <a:endParaRPr lang="en-US" dirty="0"/>
+          </a:p>
+          <a:p>
+            <a:r>
+              <a:rPr lang="ko-KR" dirty="0"/>
+              <a:t>아래 칸도 같이 봐주셨으면 합니다. 확인하지 않은 것도 분명히 해두고 싶었습니다.</a:t>
+            </a:r>
+            <a:endParaRPr lang="en-US" dirty="0"/>
+          </a:p>
+          <a:p>
+            <a:r>
+              <a:rPr lang="ko-KR" dirty="0"/>
+              <a:t>그럼 어디까지 제가 정했고, AI는 어디에 썼는지 말씀드리겠습니다.</a:t>
             </a:r>
             <a:endParaRPr lang="en-US" dirty="0"/>
           </a:p>
@@ -1462,7 +1782,12 @@
             <p:ph type="sldImg"/>
           </p:nvPr>
         </p:nvSpPr>
-        <p:spPr/>
+        <p:spPr>
+          <a:xfrm>
+            <a:off x="685800" y="1143000"/>
+            <a:ext cx="5486400" cy="3086100"/>
+          </a:xfrm>
+        </p:spPr>
       </p:sp>
       <p:sp>
         <p:nvSpPr>
@@ -1474,14 +1799,47 @@
             <p:ph type="body" idx="1"/>
           </p:nvPr>
         </p:nvSpPr>
-        <p:spPr/>
+        <p:spPr>
+          <a:xfrm>
+            <a:off x="685800" y="4572000"/>
+            <a:ext cx="5486400" cy="6400800"/>
+          </a:xfrm>
+        </p:spPr>
         <p:txBody>
           <a:bodyPr/>
           <a:lstStyle/>
           <a:p>
             <a:r>
-              <a:rPr lang="en-US" dirty="0"/>
-              <a:t>제가 한 일은 제조 문제를 정의하고, 무엇을 합격으로 볼지와 누가 무엇을 결정할 수 없는지, 어떤 기록만 근거로 인정할지를 먼저 정한 것입니다. AI 코딩 도구는 그 기준을 코드와 테스트로 빠르게 옮기고 검토하는 데 썼고, 반영 조건은 언제나 같은 테스트 통과였습니다. 다음 단계는 이 판단 모델을 실제 MES·SPC 데이터와 전자서명 위에 올리는 것입니다.</a:t>
+              <a:rPr lang="ko-KR" dirty="0"/>
+              <a:t>제가 한 일을 정리하면 이렇습니다.</a:t>
+            </a:r>
+            <a:endParaRPr lang="en-US" dirty="0"/>
+          </a:p>
+          <a:p>
+            <a:r>
+              <a:rPr lang="ko-KR" dirty="0"/>
+              <a:t>무엇이 문제인지, 무엇을 합격으로 볼지, 누가 무엇을 결정하면 안 되는지, 어떤 기록만 근거로 인정할지. 이건 코드보다 먼저 제가 정했습니다.</a:t>
+            </a:r>
+            <a:endParaRPr lang="en-US" dirty="0"/>
+          </a:p>
+          <a:p>
+            <a:r>
+              <a:rPr lang="ko-KR" dirty="0"/>
+              <a:t>AI 코딩 도구는 그 기준을 코드와 테스트로 옮기고 검토하는 데 썼습니다. 덕분에 반복은 빨랐습니다. 그래도 반영할지는 매번 같은 테스트와 실제 실행 결과를 보고 정했습니다.</a:t>
+            </a:r>
+            <a:endParaRPr lang="en-US" dirty="0"/>
+          </a:p>
+          <a:p>
+            <a:r>
+              <a:rPr lang="ko-KR" dirty="0"/>
+              <a:t>다음 단계는 이 판단 구조를 실제 MES와 설비 데이터, 그리고 전자서명 위에 올려보는 것입니다.</a:t>
+            </a:r>
+            <a:endParaRPr lang="en-US" dirty="0"/>
+          </a:p>
+          <a:p>
+            <a:r>
+              <a:rPr lang="ko-KR" dirty="0"/>
+              <a:t>감사합니다.</a:t>
             </a:r>
             <a:endParaRPr lang="en-US" dirty="0"/>
           </a:p>
@@ -2931,7 +3289,7 @@
                 <a:ea typeface="Malgun Gothic" pitchFamily="34" charset="-122"/>
                 <a:cs typeface="Malgun Gothic" pitchFamily="34" charset="-120"/>
               </a:rPr>
-              <a:t>한 PC에서 실행하는 로컬 웹 앱입니다. 판단은 모두 서버와 도메인 규칙에서 다시 검사합니다.</a:t>
+              <a:t>한 PC에서 실행하는 로컬 웹 앱입니다. 규칙 검사는 모두 서버에서 합니다.</a:t>
             </a:r>
             <a:endParaRPr lang="en-US" sz="1400" dirty="0"/>
           </a:p>
@@ -6291,7 +6649,7 @@
                 <a:ea typeface="Malgun Gothic" pitchFamily="34" charset="-122"/>
                 <a:cs typeface="Malgun Gothic" pitchFamily="34" charset="-120"/>
               </a:rPr>
-              <a:t>구현 전에 판단 기준·역할 분리·근거 요건을 계약으로 정했고, 모든 변경은 같은 확인 순서를 거쳤습니다.</a:t>
+              <a:t>구현 전에 판단 기준·역할 분리·근거 요건을 계약으로 정했고, 코드는 모두 같은 순서로 확인했습니다.</a:t>
             </a:r>
             <a:endParaRPr lang="en-US" sz="1400" dirty="0"/>
           </a:p>
@@ -6605,27 +6963,7 @@
                 <a:ea typeface="Malgun Gothic" pitchFamily="34" charset="-122"/>
                 <a:cs typeface="Malgun Gothic" pitchFamily="34" charset="-120"/>
               </a:rPr>
-              <a:t>계약에 있는 동작만</a:t>
-            </a:r>
-            <a:endParaRPr lang="en-US" sz="1250" dirty="0"/>
-          </a:p>
-          <a:p>
-            <a:pPr indent="0" marL="0">
-              <a:lnSpc>
-                <a:spcPct val="120000"/>
-              </a:lnSpc>
-              <a:buNone/>
-            </a:pPr>
-            <a:r>
-              <a:rPr lang="en-US" sz="1250" dirty="0">
-                <a:solidFill>
-                  <a:srgbClr val="53666B"/>
-                </a:solidFill>
-                <a:latin typeface="Malgun Gothic" pitchFamily="34" charset="0"/>
-                <a:ea typeface="Malgun Gothic" pitchFamily="34" charset="-122"/>
-                <a:cs typeface="Malgun Gothic" pitchFamily="34" charset="-120"/>
-              </a:rPr>
-              <a:t>구현</a:t>
+              <a:t>계약에 있는 동작만 구현</a:t>
             </a:r>
             <a:endParaRPr lang="en-US" sz="1250" dirty="0"/>
           </a:p>
@@ -7223,7 +7561,7 @@
                 <a:ea typeface="Malgun Gothic" pitchFamily="34" charset="-122"/>
                 <a:cs typeface="Malgun Gothic" pitchFamily="34" charset="-120"/>
               </a:rPr>
-              <a:t>변경 관리의 실패는 승인 서명이 없어서가 아니라, 승인과 근거와 이후 결과가 서로 끊겨 있어서 생깁니다.</a:t>
+              <a:t>문제가 드러나는 건 대개 승인 서명 뒤입니다.</a:t>
             </a:r>
             <a:endParaRPr lang="en-US" sz="1400" dirty="0"/>
           </a:p>
@@ -8008,7 +8346,7 @@
                 <a:ea typeface="Malgun Gothic" pitchFamily="34" charset="-122"/>
                 <a:cs typeface="Malgun Gothic" pitchFamily="34" charset="-120"/>
               </a:rPr>
-              <a:t>노출됐는지 다시 구성하지 못한다.</a:t>
+              <a:t>노출됐는지 되짚기 어렵다.</a:t>
             </a:r>
             <a:endParaRPr lang="en-US" sz="1300" dirty="0"/>
           </a:p>
@@ -8226,7 +8564,7 @@
                 <a:ea typeface="Malgun Gothic" pitchFamily="34" charset="-122"/>
                 <a:cs typeface="Malgun Gothic" pitchFamily="34" charset="-120"/>
               </a:rPr>
-              <a:t>검증 기준은 측정 전에 승인되고, 근거는 원천 기록에서만 오며, 요청·검토·승인은 서로 다른 사람이 합니다.</a:t>
+              <a:t>단계마다 무엇을 통과로 볼지, 누가 결정할 수 없는지 적어 두었습니다.</a:t>
             </a:r>
             <a:endParaRPr lang="en-US" sz="1400" dirty="0"/>
           </a:p>
@@ -9342,7 +9680,7 @@
                 <a:ea typeface="Malgun Gothic" pitchFamily="34" charset="-122"/>
                 <a:cs typeface="Malgun Gothic" pitchFamily="34" charset="-120"/>
               </a:rPr>
-              <a:t>같은 여섯 단계가 제품 개요 화면의 건수로 나타납니다.</a:t>
+              <a:t>앱 개요 화면 · 같은 여섯 단계의 진행 건수</a:t>
             </a:r>
             <a:endParaRPr lang="en-US" sz="1100" dirty="0"/>
           </a:p>
@@ -9511,7 +9849,7 @@
                 <a:ea typeface="Malgun Gothic" pitchFamily="34" charset="-122"/>
                 <a:cs typeface="Malgun Gothic" pitchFamily="34" charset="-120"/>
               </a:rPr>
-              <a:t>첫 검증에서 정렬 편차 0.100 mm가 기준 0.08 mm를 넘자, 기록을 덮지 않고 R2 개정에서 다시 검증해 0.052 mm로 합격했습니다.</a:t>
+              <a:t>첫 검증은 불합격이었습니다. 그 기록은 그대로 두고, 새 개정에서 다시 검증했습니다.</a:t>
             </a:r>
             <a:endParaRPr lang="en-US" sz="1400" dirty="0"/>
           </a:p>
@@ -10092,7 +10430,7 @@
                 <a:ea typeface="Malgun Gothic" pitchFamily="34" charset="-122"/>
                 <a:cs typeface="Malgun Gothic" pitchFamily="34" charset="-120"/>
               </a:rPr>
-              <a:t>권한은 화면이 아니라 서버가 다시 검사하므로, 요청자는 자신의 변경을 검토하거나 수락할 수 없습니다.</a:t>
+              <a:t>화면에서만 막는 게 아니라, 서버가 요청마다 역할을 다시 확인합니다.</a:t>
             </a:r>
             <a:endParaRPr lang="en-US" sz="1400" dirty="0"/>
           </a:p>
@@ -11382,7 +11720,7 @@
                 <a:ea typeface="Malgun Gothic" pitchFamily="34" charset="-122"/>
                 <a:cs typeface="Malgun Gothic" pitchFamily="34" charset="-120"/>
               </a:rPr>
-              <a:t>R2의 독립 결정: 검토는 독립 검토자, 수락은 승인자가 기록했습니다.</a:t>
+              <a:t>R2 독립 결정 · 검토자와 승인자가 각각 기록</a:t>
             </a:r>
             <a:endParaRPr lang="en-US" sz="1100" dirty="0"/>
           </a:p>
@@ -11495,7 +11833,7 @@
                 <a:ea typeface="Malgun Gothic" pitchFamily="34" charset="-122"/>
                 <a:cs typeface="Malgun Gothic" pitchFamily="34" charset="-120"/>
               </a:rPr>
-              <a:t>마지막 정상 관측(LKG)과 정비 이력으로 노출 구간을 잡고, 확인되지 않은 LOT은 불확실로 남겨 봉쇄 판단을 사람에게 넘깁니다.</a:t>
+              <a:t>노출 구간은 정비 이력과 마지막 정상 관측(LKG)으로 잡습니다. 정상이라고 확인할 수 없는 LOT은 제외하지 않습니다.</a:t>
             </a:r>
             <a:endParaRPr lang="en-US" sz="1400" dirty="0"/>
           </a:p>
@@ -11851,7 +12189,7 @@
                 <a:ea typeface="Malgun Gothic" pitchFamily="34" charset="-122"/>
                 <a:cs typeface="Malgun Gothic" pitchFamily="34" charset="-120"/>
               </a:rPr>
-              <a:t>LOT-A-025는 LKG 불확실 구간에 걸쳐 불확실 → 검토자가 이유와 함께 보류</a:t>
+              <a:t>LOT-A-025는 LKG 가능 구간에만 걸쳐 불확실 → 검토자가 보류</a:t>
             </a:r>
             <a:endParaRPr lang="en-US" sz="1150" dirty="0"/>
           </a:p>
@@ -12059,7 +12397,7 @@
                 <a:ea typeface="Malgun Gothic" pitchFamily="34" charset="-122"/>
                 <a:cs typeface="Malgun Gothic" pitchFamily="34" charset="-120"/>
               </a:rPr>
-              <a:t>수락은 끝이 아니며, 후속 LOT 근거가 부족하면 종결할 수 없고 재발하면 이전 결정을 지우지 않고 다시 엽니다.</a:t>
+              <a:t>08-12 수락 이후 같은 변경을 세 번 평가했고, 결과는 매번 달랐습니다.</a:t>
             </a:r>
             <a:endParaRPr lang="en-US" sz="1400" dirty="0"/>
           </a:p>
@@ -12628,7 +12966,7 @@
                 <a:ea typeface="Malgun Gothic" pitchFamily="34" charset="-122"/>
                 <a:cs typeface="Malgun Gothic" pitchFamily="34" charset="-120"/>
               </a:rPr>
-              <a:t>승인자 · 평가자와 다른 사람</a:t>
+              <a:t>승인자가 종결 · 평가자와 다른 사람</a:t>
             </a:r>
             <a:endParaRPr lang="en-US" sz="1150" dirty="0"/>
           </a:p>
@@ -13208,7 +13546,7 @@
                 <a:ea typeface="Malgun Gothic" pitchFamily="34" charset="-122"/>
                 <a:cs typeface="Malgun Gothic" pitchFamily="34" charset="-120"/>
               </a:rPr>
-              <a:t>종결에는 합격한 최근 확인이 필요하고,</a:t>
+              <a:t>가장 최근 평가가 합격이어야 종결할 수 있고,</a:t>
             </a:r>
             <a:endParaRPr lang="en-US" sz="1200" dirty="0"/>
           </a:p>
@@ -13299,7 +13637,7 @@
                 <a:ea typeface="Malgun Gothic" pitchFamily="34" charset="-122"/>
                 <a:cs typeface="Malgun Gothic" pitchFamily="34" charset="-120"/>
               </a:rPr>
-              <a:t>무엇을 검증했고, 무엇은 증명하지 않는가</a:t>
+              <a:t>어디까지 확인했나</a:t>
             </a:r>
             <a:endParaRPr lang="en-US" sz="2800" dirty="0"/>
           </a:p>
@@ -13341,7 +13679,7 @@
                 <a:ea typeface="Malgun Gothic" pitchFamily="34" charset="-122"/>
                 <a:cs typeface="Malgun Gothic" pitchFamily="34" charset="-120"/>
               </a:rPr>
-              <a:t>규칙은 자동 테스트로, 배포본은 오프라인 검증기로, 화면은 실제 브라우저로 확인했고, 실제 공장 연동은 증명 범위 밖입니다.</a:t>
+              <a:t>앞에서 본 동작은 자동 테스트와 실제 앱 실행으로 확인했습니다.</a:t>
             </a:r>
             <a:endParaRPr lang="en-US" sz="1400" dirty="0"/>
           </a:p>
@@ -14048,7 +14386,7 @@
                 <a:ea typeface="Malgun Gothic" pitchFamily="34" charset="-122"/>
                 <a:cs typeface="Malgun Gothic" pitchFamily="34" charset="-120"/>
               </a:rPr>
-              <a:t>Chromium · 전 화면 순회</a:t>
+              <a:t>Chromium(Playwright)</a:t>
             </a:r>
             <a:endParaRPr lang="en-US" sz="1100" dirty="0"/>
           </a:p>
@@ -14068,7 +14406,27 @@
                 <a:ea typeface="Malgun Gothic" pitchFamily="34" charset="-122"/>
                 <a:cs typeface="Malgun Gothic" pitchFamily="34" charset="-120"/>
               </a:rPr>
-              <a:t>화면 문구의 영어 문장·UUID 0건</a:t>
+              <a:t>전 화면 순회</a:t>
+            </a:r>
+            <a:endParaRPr lang="en-US" sz="1100" dirty="0"/>
+          </a:p>
+          <a:p>
+            <a:pPr indent="0" marL="0">
+              <a:lnSpc>
+                <a:spcPct val="120000"/>
+              </a:lnSpc>
+              <a:buNone/>
+            </a:pPr>
+            <a:r>
+              <a:rPr lang="en-US" sz="1100" dirty="0">
+                <a:solidFill>
+                  <a:srgbClr val="53666B"/>
+                </a:solidFill>
+                <a:latin typeface="Malgun Gothic" pitchFamily="34" charset="0"/>
+                <a:ea typeface="Malgun Gothic" pitchFamily="34" charset="-122"/>
+                <a:cs typeface="Malgun Gothic" pitchFamily="34" charset="-120"/>
+              </a:rPr>
+              <a:t>표시 문구 영어 문장·UUID 0건</a:t>
             </a:r>
             <a:endParaRPr lang="en-US" sz="1100" dirty="0"/>
           </a:p>
@@ -14176,7 +14534,7 @@
                 <a:ea typeface="Malgun Gothic" pitchFamily="34" charset="-122"/>
                 <a:cs typeface="Malgun Gothic" pitchFamily="34" charset="-120"/>
               </a:rPr>
-              <a:t>합성 정렬·AOI 공정 데이터로 검증했습니다. 실제 MES·설비 연동, 사용자 인증·전자서명, 실제 공정 기준값의 타당성은 이 결과가 증명하지 않습니다.</a:t>
+              <a:t>합성 정렬·AOI 공정 데이터로 검증했습니다. 실제 MES·설비 연동, 사용자 인증·전자서명, 실제 공정 기준값의 타당성은 이 범위 밖입니다.</a:t>
             </a:r>
             <a:endParaRPr lang="en-US" sz="1300" dirty="0"/>
           </a:p>
@@ -14289,7 +14647,7 @@
                 <a:ea typeface="Malgun Gothic" pitchFamily="34" charset="-122"/>
                 <a:cs typeface="Malgun Gothic" pitchFamily="34" charset="-120"/>
               </a:rPr>
-              <a:t>판단 기준은 제가 정의했고 AI는 구현과 검증을 빠르게 반복하는 도구였으며, 다음 단계는 이 기준을 실제 MES 데이터에 올리는 것입니다.</a:t>
+              <a:t>지금은 합성 데이터에서 동작합니다. 다음은 실제 MES·설비 데이터와 연결하는 일입니다.</a:t>
             </a:r>
             <a:endParaRPr lang="en-US" sz="1400" dirty="0"/>
           </a:p>
@@ -14630,7 +14988,7 @@
                 <a:ea typeface="Malgun Gothic" pitchFamily="34" charset="-122"/>
                 <a:cs typeface="Malgun Gothic" pitchFamily="34" charset="-120"/>
               </a:rPr>
-              <a:t>정의한 기준을 코드로 옮기는 구현</a:t>
+              <a:t>기준을 코드로 옮기는 구현</a:t>
             </a:r>
             <a:endParaRPr lang="en-US" sz="1350" dirty="0"/>
           </a:p>
@@ -14651,7 +15009,7 @@
                 <a:ea typeface="Malgun Gothic" pitchFamily="34" charset="-122"/>
                 <a:cs typeface="Malgun Gothic" pitchFamily="34" charset="-120"/>
               </a:rPr>
-              <a:t>테스트 작성과 코드 검토의 반복</a:t>
+              <a:t>테스트 작성과 코드 검토</a:t>
             </a:r>
             <a:endParaRPr lang="en-US" sz="1350" dirty="0"/>
           </a:p>
@@ -14672,7 +15030,7 @@
                 <a:ea typeface="Malgun Gothic" pitchFamily="34" charset="-122"/>
                 <a:cs typeface="Malgun Gothic" pitchFamily="34" charset="-120"/>
               </a:rPr>
-              <a:t>반영 조건은 같은 테스트 통과</a:t>
+              <a:t>반영 여부는 테스트와 실행으로 결정</a:t>
             </a:r>
             <a:endParaRPr lang="en-US" sz="1350" dirty="0"/>
           </a:p>
@@ -14781,7 +15139,7 @@
                 <a:ea typeface="Malgun Gothic" pitchFamily="34" charset="-122"/>
                 <a:cs typeface="Malgun Gothic" pitchFamily="34" charset="-120"/>
               </a:rPr>
-              <a:t>MES·SPC 실데이터 연동</a:t>
+              <a:t>MES·설비·SPC 실데이터 연동</a:t>
             </a:r>
             <a:endParaRPr lang="en-US" sz="1350" dirty="0"/>
           </a:p>
@@ -14862,7 +15220,7 @@
                 <a:ea typeface="Malgun Gothic" pitchFamily="34" charset="-122"/>
                 <a:cs typeface="Malgun Gothic" pitchFamily="34" charset="-120"/>
               </a:rPr>
-              <a:t>무엇을 만들지, 어떤 조건에서 통과시킬지는 제가 정의했습니다.</a:t>
+              <a:t>무엇을 만들지, 어떤 조건에서 통과시킬지는 제가 정했습니다.</a:t>
             </a:r>
             <a:endParaRPr lang="en-US" sz="2000" dirty="0"/>
           </a:p>

</xml_diff>